<commit_message>
General Summary slide: single column
Co-Authored-By: Claude Opus 5.5 <noreply@anthropic.com>
Claude-Session: https://claude.ai/code/session_01U1DJd2gSQyyin3TdCJkPvd
</commit_message>
<xml_diff>
--- a/Vorl_2/slides/general-summary-paper2.pptx
+++ b/Vorl_2/slides/general-summary-paper2.pptx
@@ -508,7 +508,7 @@
           <a:p/>
           <a:p>
             <a:r>
-              <a:t>1. Link to last week: "Last week's papers asked why so few working artifacts exist. This paper asks why making good artifacts is hard, and what could be done about it." (point to the green questions)</a:t>
+              <a:t>1. Link to last week: "Last week's papers asked why so few working artifacts exist. This paper asks why making good artifacts is hard, and what could be done about it."</a:t>
             </a:r>
           </a:p>
           <a:p/>
@@ -3618,8 +3618,8 @@
         </p:nvSpPr>
         <p:spPr>
           <a:xfrm>
-            <a:off x="640080" y="1600200"/>
-            <a:ext cx="3017520" cy="4389120"/>
+            <a:off x="640080" y="1554480"/>
+            <a:ext cx="10908792" cy="4754880"/>
           </a:xfrm>
           <a:prstGeom prst="rect">
             <a:avLst/>
@@ -3634,66 +3634,20 @@
           <a:p>
             <a:pPr algn="l">
               <a:spcAft>
-                <a:spcPts val="1800"/>
+                <a:spcPts val="1200"/>
               </a:spcAft>
             </a:pPr>
             <a:r>
-              <a:rPr sz="2400" b="1" i="0">
+              <a:rPr sz="2000" b="0" i="0">
                 <a:solidFill>
-                  <a:srgbClr val="00883A"/>
+                  <a:srgbClr val="1A1A1A"/>
                 </a:solidFill>
                 <a:latin typeface="Arial"/>
               </a:rPr>
-              <a:t>Why is making good artifacts hard?</a:t>
-            </a:r>
-          </a:p>
-          <a:p>
-            <a:pPr algn="l">
-              <a:spcAft>
-                <a:spcPts val="1800"/>
-              </a:spcAft>
-            </a:pPr>
-            <a:r>
-              <a:rPr sz="2400" b="1" i="0">
-                <a:solidFill>
-                  <a:srgbClr val="00883A"/>
-                </a:solidFill>
-                <a:latin typeface="Arial"/>
-              </a:rPr>
-              <a:t>Potential solutions to this?</a:t>
-            </a:r>
-          </a:p>
-        </p:txBody>
-      </p:sp>
-      <p:sp>
-        <p:nvSpPr>
-          <p:cNvPr id="4" name="TextBox 3"/>
-          <p:cNvSpPr txBox="1"/>
-          <p:nvPr/>
-        </p:nvSpPr>
-        <p:spPr>
-          <a:xfrm>
-            <a:off x="3968496" y="1463040"/>
-            <a:ext cx="7589520" cy="4754880"/>
-          </a:xfrm>
-          <a:prstGeom prst="rect">
-            <a:avLst/>
-          </a:prstGeom>
-          <a:noFill/>
-        </p:spPr>
-        <p:txBody>
-          <a:bodyPr wrap="square">
-            <a:spAutoFit/>
-          </a:bodyPr>
-          <a:lstStyle/>
-          <a:p>
-            <a:pPr algn="l">
-              <a:spcAft>
-                <a:spcPts val="1200"/>
-              </a:spcAft>
-            </a:pPr>
-            <a:r>
-              <a:rPr sz="1900" b="1" i="0">
+              <a:t>• </a:t>
+            </a:r>
+            <a:r>
+              <a:rPr sz="2000" b="1" i="0">
                 <a:solidFill>
                   <a:srgbClr val="00883A"/>
                 </a:solidFill>
@@ -3702,7 +3656,7 @@
               <a:t>Paper: </a:t>
             </a:r>
             <a:r>
-              <a:rPr sz="1900" b="0" i="0">
+              <a:rPr sz="2000" b="0" i="0">
                 <a:solidFill>
                   <a:srgbClr val="1A1A1A"/>
                 </a:solidFill>
@@ -3718,7 +3672,16 @@
               </a:spcAft>
             </a:pPr>
             <a:r>
-              <a:rPr sz="1900" b="1" i="0">
+              <a:rPr sz="2000" b="0" i="0">
+                <a:solidFill>
+                  <a:srgbClr val="1A1A1A"/>
+                </a:solidFill>
+                <a:latin typeface="Arial"/>
+              </a:rPr>
+              <a:t>• </a:t>
+            </a:r>
+            <a:r>
+              <a:rPr sz="2000" b="1" i="0">
                 <a:solidFill>
                   <a:srgbClr val="00883A"/>
                 </a:solidFill>
@@ -3727,7 +3690,7 @@
               <a:t>Did: </a:t>
             </a:r>
             <a:r>
-              <a:rPr sz="1900" b="0" i="0">
+              <a:rPr sz="2000" b="0" i="0">
                 <a:solidFill>
                   <a:srgbClr val="1A1A1A"/>
                 </a:solidFill>
@@ -3743,7 +3706,16 @@
               </a:spcAft>
             </a:pPr>
             <a:r>
-              <a:rPr sz="1900" b="1" i="0">
+              <a:rPr sz="2000" b="0" i="0">
+                <a:solidFill>
+                  <a:srgbClr val="1A1A1A"/>
+                </a:solidFill>
+                <a:latin typeface="Arial"/>
+              </a:rPr>
+              <a:t>• </a:t>
+            </a:r>
+            <a:r>
+              <a:rPr sz="2000" b="1" i="0">
                 <a:solidFill>
                   <a:srgbClr val="00883A"/>
                 </a:solidFill>
@@ -3752,7 +3724,7 @@
               <a:t>Found: </a:t>
             </a:r>
             <a:r>
-              <a:rPr sz="1900" b="0" i="0">
+              <a:rPr sz="2000" b="0" i="0">
                 <a:solidFill>
                   <a:srgbClr val="1A1A1A"/>
                 </a:solidFill>
@@ -3768,7 +3740,16 @@
               </a:spcAft>
             </a:pPr>
             <a:r>
-              <a:rPr sz="1900" b="1" i="0">
+              <a:rPr sz="2000" b="0" i="0">
+                <a:solidFill>
+                  <a:srgbClr val="1A1A1A"/>
+                </a:solidFill>
+                <a:latin typeface="Arial"/>
+              </a:rPr>
+              <a:t>• </a:t>
+            </a:r>
+            <a:r>
+              <a:rPr sz="2000" b="1" i="0">
                 <a:solidFill>
                   <a:srgbClr val="00883A"/>
                 </a:solidFill>
@@ -3777,7 +3758,7 @@
               <a:t>Analysed: </a:t>
             </a:r>
             <a:r>
-              <a:rPr sz="1900" b="0" i="0">
+              <a:rPr sz="2000" b="0" i="0">
                 <a:solidFill>
                   <a:srgbClr val="1A1A1A"/>
                 </a:solidFill>
@@ -3793,7 +3774,16 @@
               </a:spcAft>
             </a:pPr>
             <a:r>
-              <a:rPr sz="1900" b="1" i="0">
+              <a:rPr sz="2000" b="0" i="0">
+                <a:solidFill>
+                  <a:srgbClr val="1A1A1A"/>
+                </a:solidFill>
+                <a:latin typeface="Arial"/>
+              </a:rPr>
+              <a:t>• </a:t>
+            </a:r>
+            <a:r>
+              <a:rPr sz="2000" b="1" i="0">
                 <a:solidFill>
                   <a:srgbClr val="00883A"/>
                 </a:solidFill>
@@ -3802,7 +3792,7 @@
               <a:t>Then: </a:t>
             </a:r>
             <a:r>
-              <a:rPr sz="1900" b="0" i="0">
+              <a:rPr sz="2000" b="0" i="0">
                 <a:solidFill>
                   <a:srgbClr val="1A1A1A"/>
                 </a:solidFill>

</xml_diff>